<commit_message>
modell + überarbeitung begonnen
</commit_message>
<xml_diff>
--- a/02_paper/02_study/02_expertise_paper/pictures/Professional_Competence_Model.pptx
+++ b/02_paper/02_study/02_expertise_paper/pictures/Professional_Competence_Model.pptx
@@ -117,12 +117,12 @@
   <pc:docChgLst>
     <pc:chgData name="Mandy Klatt" userId="505858402c07da9d" providerId="LiveId" clId="{FA5EC466-BD05-4DCC-91DA-EA1E98BFA00F}"/>
     <pc:docChg chg="undo redo custSel modSld">
-      <pc:chgData name="Mandy Klatt" userId="505858402c07da9d" providerId="LiveId" clId="{FA5EC466-BD05-4DCC-91DA-EA1E98BFA00F}" dt="2025-04-17T11:26:37.451" v="663" actId="1582"/>
+      <pc:chgData name="Mandy Klatt" userId="505858402c07da9d" providerId="LiveId" clId="{FA5EC466-BD05-4DCC-91DA-EA1E98BFA00F}" dt="2025-04-30T08:41:24.253" v="828" actId="1076"/>
       <pc:docMkLst>
         <pc:docMk/>
       </pc:docMkLst>
       <pc:sldChg chg="addSp delSp modSp mod">
-        <pc:chgData name="Mandy Klatt" userId="505858402c07da9d" providerId="LiveId" clId="{FA5EC466-BD05-4DCC-91DA-EA1E98BFA00F}" dt="2025-04-17T11:26:37.451" v="663" actId="1582"/>
+        <pc:chgData name="Mandy Klatt" userId="505858402c07da9d" providerId="LiveId" clId="{FA5EC466-BD05-4DCC-91DA-EA1E98BFA00F}" dt="2025-04-30T08:41:24.253" v="828" actId="1076"/>
         <pc:sldMkLst>
           <pc:docMk/>
           <pc:sldMk cId="387449015" sldId="256"/>
@@ -136,7 +136,7 @@
           </ac:spMkLst>
         </pc:spChg>
         <pc:spChg chg="mod">
-          <ac:chgData name="Mandy Klatt" userId="505858402c07da9d" providerId="LiveId" clId="{FA5EC466-BD05-4DCC-91DA-EA1E98BFA00F}" dt="2025-04-17T10:47:59.709" v="645" actId="20577"/>
+          <ac:chgData name="Mandy Klatt" userId="505858402c07da9d" providerId="LiveId" clId="{FA5EC466-BD05-4DCC-91DA-EA1E98BFA00F}" dt="2025-04-30T08:40:48.560" v="825" actId="1076"/>
           <ac:spMkLst>
             <pc:docMk/>
             <pc:sldMk cId="387449015" sldId="256"/>
@@ -144,7 +144,7 @@
           </ac:spMkLst>
         </pc:spChg>
         <pc:spChg chg="mod">
-          <ac:chgData name="Mandy Klatt" userId="505858402c07da9d" providerId="LiveId" clId="{FA5EC466-BD05-4DCC-91DA-EA1E98BFA00F}" dt="2025-04-17T10:47:57.053" v="643" actId="20577"/>
+          <ac:chgData name="Mandy Klatt" userId="505858402c07da9d" providerId="LiveId" clId="{FA5EC466-BD05-4DCC-91DA-EA1E98BFA00F}" dt="2025-04-30T08:35:47.528" v="797" actId="164"/>
           <ac:spMkLst>
             <pc:docMk/>
             <pc:sldMk cId="387449015" sldId="256"/>
@@ -152,7 +152,7 @@
           </ac:spMkLst>
         </pc:spChg>
         <pc:spChg chg="mod">
-          <ac:chgData name="Mandy Klatt" userId="505858402c07da9d" providerId="LiveId" clId="{FA5EC466-BD05-4DCC-91DA-EA1E98BFA00F}" dt="2025-04-17T10:48:39.434" v="649" actId="1076"/>
+          <ac:chgData name="Mandy Klatt" userId="505858402c07da9d" providerId="LiveId" clId="{FA5EC466-BD05-4DCC-91DA-EA1E98BFA00F}" dt="2025-04-30T08:40:55.062" v="826" actId="1076"/>
           <ac:spMkLst>
             <pc:docMk/>
             <pc:sldMk cId="387449015" sldId="256"/>
@@ -160,7 +160,7 @@
           </ac:spMkLst>
         </pc:spChg>
         <pc:spChg chg="add mod">
-          <ac:chgData name="Mandy Klatt" userId="505858402c07da9d" providerId="LiveId" clId="{FA5EC466-BD05-4DCC-91DA-EA1E98BFA00F}" dt="2025-04-17T10:49:14.250" v="651" actId="1076"/>
+          <ac:chgData name="Mandy Klatt" userId="505858402c07da9d" providerId="LiveId" clId="{FA5EC466-BD05-4DCC-91DA-EA1E98BFA00F}" dt="2025-04-30T08:37:35.901" v="814" actId="1038"/>
           <ac:spMkLst>
             <pc:docMk/>
             <pc:sldMk cId="387449015" sldId="256"/>
@@ -168,11 +168,27 @@
           </ac:spMkLst>
         </pc:spChg>
         <pc:spChg chg="add mod">
-          <ac:chgData name="Mandy Klatt" userId="505858402c07da9d" providerId="LiveId" clId="{FA5EC466-BD05-4DCC-91DA-EA1E98BFA00F}" dt="2025-04-17T11:26:18.258" v="659" actId="1076"/>
+          <ac:chgData name="Mandy Klatt" userId="505858402c07da9d" providerId="LiveId" clId="{FA5EC466-BD05-4DCC-91DA-EA1E98BFA00F}" dt="2025-04-30T08:37:35.901" v="814" actId="1038"/>
           <ac:spMkLst>
             <pc:docMk/>
             <pc:sldMk cId="387449015" sldId="256"/>
             <ac:spMk id="12" creationId="{47CF6F82-B69D-4724-849C-DF7E9AA84FD5}"/>
+          </ac:spMkLst>
+        </pc:spChg>
+        <pc:spChg chg="add mod">
+          <ac:chgData name="Mandy Klatt" userId="505858402c07da9d" providerId="LiveId" clId="{FA5EC466-BD05-4DCC-91DA-EA1E98BFA00F}" dt="2025-04-30T08:40:25.860" v="821" actId="164"/>
+          <ac:spMkLst>
+            <pc:docMk/>
+            <pc:sldMk cId="387449015" sldId="256"/>
+            <ac:spMk id="13" creationId="{687BC613-2B38-4EB9-A500-DD27CE840820}"/>
+          </ac:spMkLst>
+        </pc:spChg>
+        <pc:spChg chg="add mod">
+          <ac:chgData name="Mandy Klatt" userId="505858402c07da9d" providerId="LiveId" clId="{FA5EC466-BD05-4DCC-91DA-EA1E98BFA00F}" dt="2025-04-30T08:40:25.860" v="821" actId="164"/>
+          <ac:spMkLst>
+            <pc:docMk/>
+            <pc:sldMk cId="387449015" sldId="256"/>
+            <ac:spMk id="14" creationId="{2CA634B0-2179-4260-9524-88AE3E6D6885}"/>
           </ac:spMkLst>
         </pc:spChg>
         <pc:spChg chg="add del mod">
@@ -184,7 +200,7 @@
           </ac:spMkLst>
         </pc:spChg>
         <pc:spChg chg="add mod">
-          <ac:chgData name="Mandy Klatt" userId="505858402c07da9d" providerId="LiveId" clId="{FA5EC466-BD05-4DCC-91DA-EA1E98BFA00F}" dt="2025-04-17T10:47:54.087" v="641" actId="20577"/>
+          <ac:chgData name="Mandy Klatt" userId="505858402c07da9d" providerId="LiveId" clId="{FA5EC466-BD05-4DCC-91DA-EA1E98BFA00F}" dt="2025-04-30T08:40:25.860" v="821" actId="164"/>
           <ac:spMkLst>
             <pc:docMk/>
             <pc:sldMk cId="387449015" sldId="256"/>
@@ -192,15 +208,31 @@
           </ac:spMkLst>
         </pc:spChg>
         <pc:spChg chg="add mod">
-          <ac:chgData name="Mandy Klatt" userId="505858402c07da9d" providerId="LiveId" clId="{FA5EC466-BD05-4DCC-91DA-EA1E98BFA00F}" dt="2025-04-17T10:48:46.671" v="650" actId="1076"/>
+          <ac:chgData name="Mandy Klatt" userId="505858402c07da9d" providerId="LiveId" clId="{FA5EC466-BD05-4DCC-91DA-EA1E98BFA00F}" dt="2025-04-30T08:41:09.063" v="827" actId="1076"/>
           <ac:spMkLst>
             <pc:docMk/>
             <pc:sldMk cId="387449015" sldId="256"/>
             <ac:spMk id="53" creationId="{31FF52EA-BB8A-4921-8CCF-2ADDC3349751}"/>
           </ac:spMkLst>
         </pc:spChg>
-        <pc:cxnChg chg="add mod">
-          <ac:chgData name="Mandy Klatt" userId="505858402c07da9d" providerId="LiveId" clId="{FA5EC466-BD05-4DCC-91DA-EA1E98BFA00F}" dt="2025-04-17T10:42:58.821" v="616" actId="1076"/>
+        <pc:grpChg chg="add mod">
+          <ac:chgData name="Mandy Klatt" userId="505858402c07da9d" providerId="LiveId" clId="{FA5EC466-BD05-4DCC-91DA-EA1E98BFA00F}" dt="2025-04-30T08:40:43.827" v="824" actId="1076"/>
+          <ac:grpSpMkLst>
+            <pc:docMk/>
+            <pc:sldMk cId="387449015" sldId="256"/>
+            <ac:grpSpMk id="2" creationId="{38FC2BD1-3E2A-4365-B695-09A0D3D0AFA9}"/>
+          </ac:grpSpMkLst>
+        </pc:grpChg>
+        <pc:grpChg chg="add mod">
+          <ac:chgData name="Mandy Klatt" userId="505858402c07da9d" providerId="LiveId" clId="{FA5EC466-BD05-4DCC-91DA-EA1E98BFA00F}" dt="2025-04-30T08:40:38.402" v="823" actId="1076"/>
+          <ac:grpSpMkLst>
+            <pc:docMk/>
+            <pc:sldMk cId="387449015" sldId="256"/>
+            <ac:grpSpMk id="3" creationId="{9488C15B-1263-4A15-B38F-E1C3D5E2AF1B}"/>
+          </ac:grpSpMkLst>
+        </pc:grpChg>
+        <pc:cxnChg chg="add del mod">
+          <ac:chgData name="Mandy Klatt" userId="505858402c07da9d" providerId="LiveId" clId="{FA5EC466-BD05-4DCC-91DA-EA1E98BFA00F}" dt="2025-04-28T15:24:51.052" v="664" actId="478"/>
           <ac:cxnSpMkLst>
             <pc:docMk/>
             <pc:sldMk cId="387449015" sldId="256"/>
@@ -213,6 +245,14 @@
             <pc:docMk/>
             <pc:sldMk cId="387449015" sldId="256"/>
             <ac:cxnSpMk id="3" creationId="{57EDCD8A-90CA-43EF-8FF5-6D5BD0A1E83C}"/>
+          </ac:cxnSpMkLst>
+        </pc:cxnChg>
+        <pc:cxnChg chg="add del mod">
+          <ac:chgData name="Mandy Klatt" userId="505858402c07da9d" providerId="LiveId" clId="{FA5EC466-BD05-4DCC-91DA-EA1E98BFA00F}" dt="2025-04-30T08:29:42.254" v="731" actId="478"/>
+          <ac:cxnSpMkLst>
+            <pc:docMk/>
+            <pc:sldMk cId="387449015" sldId="256"/>
+            <ac:cxnSpMk id="7" creationId="{C23AF0E5-551E-48AD-88F2-06FAB92F3287}"/>
           </ac:cxnSpMkLst>
         </pc:cxnChg>
         <pc:cxnChg chg="add del mod">
@@ -232,6 +272,14 @@
           </ac:cxnSpMkLst>
         </pc:cxnChg>
         <pc:cxnChg chg="add del mod">
+          <ac:chgData name="Mandy Klatt" userId="505858402c07da9d" providerId="LiveId" clId="{FA5EC466-BD05-4DCC-91DA-EA1E98BFA00F}" dt="2025-04-30T08:29:43.895" v="732" actId="478"/>
+          <ac:cxnSpMkLst>
+            <pc:docMk/>
+            <pc:sldMk cId="387449015" sldId="256"/>
+            <ac:cxnSpMk id="9" creationId="{09B882D0-6360-4930-8C63-ABC1B06D6A9E}"/>
+          </ac:cxnSpMkLst>
+        </pc:cxnChg>
+        <pc:cxnChg chg="add del mod">
           <ac:chgData name="Mandy Klatt" userId="505858402c07da9d" providerId="LiveId" clId="{FA5EC466-BD05-4DCC-91DA-EA1E98BFA00F}" dt="2025-04-02T13:19:55.046" v="368" actId="478"/>
           <ac:cxnSpMkLst>
             <pc:docMk/>
@@ -248,7 +296,7 @@
           </ac:cxnSpMkLst>
         </pc:cxnChg>
         <pc:cxnChg chg="add mod">
-          <ac:chgData name="Mandy Klatt" userId="505858402c07da9d" providerId="LiveId" clId="{FA5EC466-BD05-4DCC-91DA-EA1E98BFA00F}" dt="2025-04-17T11:26:37.451" v="663" actId="1582"/>
+          <ac:chgData name="Mandy Klatt" userId="505858402c07da9d" providerId="LiveId" clId="{FA5EC466-BD05-4DCC-91DA-EA1E98BFA00F}" dt="2025-04-30T08:37:35.901" v="814" actId="1038"/>
           <ac:cxnSpMkLst>
             <pc:docMk/>
             <pc:sldMk cId="387449015" sldId="256"/>
@@ -271,12 +319,36 @@
             <ac:cxnSpMk id="14" creationId="{2466CEA6-D647-4DAF-999B-840EC68497E8}"/>
           </ac:cxnSpMkLst>
         </pc:cxnChg>
+        <pc:cxnChg chg="add del">
+          <ac:chgData name="Mandy Klatt" userId="505858402c07da9d" providerId="LiveId" clId="{FA5EC466-BD05-4DCC-91DA-EA1E98BFA00F}" dt="2025-04-28T15:27:39.803" v="683" actId="478"/>
+          <ac:cxnSpMkLst>
+            <pc:docMk/>
+            <pc:sldMk cId="387449015" sldId="256"/>
+            <ac:cxnSpMk id="14" creationId="{AB2CED50-7338-4287-948D-EA31EC94B24F}"/>
+          </ac:cxnSpMkLst>
+        </pc:cxnChg>
+        <pc:cxnChg chg="add del mod">
+          <ac:chgData name="Mandy Klatt" userId="505858402c07da9d" providerId="LiveId" clId="{FA5EC466-BD05-4DCC-91DA-EA1E98BFA00F}" dt="2025-04-30T08:29:45.019" v="733" actId="478"/>
+          <ac:cxnSpMkLst>
+            <pc:docMk/>
+            <pc:sldMk cId="387449015" sldId="256"/>
+            <ac:cxnSpMk id="17" creationId="{4DF94371-077F-4DF8-B0B8-4785329BEA01}"/>
+          </ac:cxnSpMkLst>
+        </pc:cxnChg>
         <pc:cxnChg chg="add del mod">
           <ac:chgData name="Mandy Klatt" userId="505858402c07da9d" providerId="LiveId" clId="{FA5EC466-BD05-4DCC-91DA-EA1E98BFA00F}" dt="2025-03-24T13:02:02.953" v="270" actId="11529"/>
           <ac:cxnSpMkLst>
             <pc:docMk/>
             <pc:sldMk cId="387449015" sldId="256"/>
             <ac:cxnSpMk id="17" creationId="{B7B11571-5A4A-403E-B2A6-5A7E9850AE50}"/>
+          </ac:cxnSpMkLst>
+        </pc:cxnChg>
+        <pc:cxnChg chg="add mod">
+          <ac:chgData name="Mandy Klatt" userId="505858402c07da9d" providerId="LiveId" clId="{FA5EC466-BD05-4DCC-91DA-EA1E98BFA00F}" dt="2025-04-30T08:41:24.253" v="828" actId="1076"/>
+          <ac:cxnSpMkLst>
+            <pc:docMk/>
+            <pc:sldMk cId="387449015" sldId="256"/>
+            <ac:cxnSpMk id="18" creationId="{AA9571B3-9964-4865-B68D-64DC0FA175FF}"/>
           </ac:cxnSpMkLst>
         </pc:cxnChg>
         <pc:cxnChg chg="add del mod">
@@ -319,16 +391,16 @@
             <ac:cxnSpMk id="30" creationId="{2A7F053A-6E4B-4653-ACBB-0F27BE29A507}"/>
           </ac:cxnSpMkLst>
         </pc:cxnChg>
-        <pc:cxnChg chg="add mod">
-          <ac:chgData name="Mandy Klatt" userId="505858402c07da9d" providerId="LiveId" clId="{FA5EC466-BD05-4DCC-91DA-EA1E98BFA00F}" dt="2025-04-17T10:43:11.404" v="618" actId="1076"/>
+        <pc:cxnChg chg="add del mod">
+          <ac:chgData name="Mandy Klatt" userId="505858402c07da9d" providerId="LiveId" clId="{FA5EC466-BD05-4DCC-91DA-EA1E98BFA00F}" dt="2025-04-28T15:25:13.257" v="666" actId="478"/>
           <ac:cxnSpMkLst>
             <pc:docMk/>
             <pc:sldMk cId="387449015" sldId="256"/>
             <ac:cxnSpMk id="33" creationId="{3914D202-863F-4433-AF5F-12A385953860}"/>
           </ac:cxnSpMkLst>
         </pc:cxnChg>
-        <pc:cxnChg chg="add mod">
-          <ac:chgData name="Mandy Klatt" userId="505858402c07da9d" providerId="LiveId" clId="{FA5EC466-BD05-4DCC-91DA-EA1E98BFA00F}" dt="2025-04-17T10:48:39.434" v="649" actId="1076"/>
+        <pc:cxnChg chg="add del mod">
+          <ac:chgData name="Mandy Klatt" userId="505858402c07da9d" providerId="LiveId" clId="{FA5EC466-BD05-4DCC-91DA-EA1E98BFA00F}" dt="2025-04-28T15:25:14.644" v="667" actId="478"/>
           <ac:cxnSpMkLst>
             <pc:docMk/>
             <pc:sldMk cId="387449015" sldId="256"/>
@@ -488,7 +560,7 @@
           <a:p>
             <a:fld id="{D999196E-D4C6-4B69-A492-D961CA2AEF86}" type="datetimeFigureOut">
               <a:rPr lang="de-DE" smtClean="0"/>
-              <a:t>17.04.2025</a:t>
+              <a:t>29.04.2025</a:t>
             </a:fld>
             <a:endParaRPr lang="de-DE"/>
           </a:p>
@@ -686,7 +758,7 @@
           <a:p>
             <a:fld id="{D999196E-D4C6-4B69-A492-D961CA2AEF86}" type="datetimeFigureOut">
               <a:rPr lang="de-DE" smtClean="0"/>
-              <a:t>17.04.2025</a:t>
+              <a:t>29.04.2025</a:t>
             </a:fld>
             <a:endParaRPr lang="de-DE"/>
           </a:p>
@@ -894,7 +966,7 @@
           <a:p>
             <a:fld id="{D999196E-D4C6-4B69-A492-D961CA2AEF86}" type="datetimeFigureOut">
               <a:rPr lang="de-DE" smtClean="0"/>
-              <a:t>17.04.2025</a:t>
+              <a:t>29.04.2025</a:t>
             </a:fld>
             <a:endParaRPr lang="de-DE"/>
           </a:p>
@@ -1092,7 +1164,7 @@
           <a:p>
             <a:fld id="{D999196E-D4C6-4B69-A492-D961CA2AEF86}" type="datetimeFigureOut">
               <a:rPr lang="de-DE" smtClean="0"/>
-              <a:t>17.04.2025</a:t>
+              <a:t>29.04.2025</a:t>
             </a:fld>
             <a:endParaRPr lang="de-DE"/>
           </a:p>
@@ -1367,7 +1439,7 @@
           <a:p>
             <a:fld id="{D999196E-D4C6-4B69-A492-D961CA2AEF86}" type="datetimeFigureOut">
               <a:rPr lang="de-DE" smtClean="0"/>
-              <a:t>17.04.2025</a:t>
+              <a:t>29.04.2025</a:t>
             </a:fld>
             <a:endParaRPr lang="de-DE"/>
           </a:p>
@@ -1632,7 +1704,7 @@
           <a:p>
             <a:fld id="{D999196E-D4C6-4B69-A492-D961CA2AEF86}" type="datetimeFigureOut">
               <a:rPr lang="de-DE" smtClean="0"/>
-              <a:t>17.04.2025</a:t>
+              <a:t>29.04.2025</a:t>
             </a:fld>
             <a:endParaRPr lang="de-DE"/>
           </a:p>
@@ -2044,7 +2116,7 @@
           <a:p>
             <a:fld id="{D999196E-D4C6-4B69-A492-D961CA2AEF86}" type="datetimeFigureOut">
               <a:rPr lang="de-DE" smtClean="0"/>
-              <a:t>17.04.2025</a:t>
+              <a:t>29.04.2025</a:t>
             </a:fld>
             <a:endParaRPr lang="de-DE"/>
           </a:p>
@@ -2185,7 +2257,7 @@
           <a:p>
             <a:fld id="{D999196E-D4C6-4B69-A492-D961CA2AEF86}" type="datetimeFigureOut">
               <a:rPr lang="de-DE" smtClean="0"/>
-              <a:t>17.04.2025</a:t>
+              <a:t>29.04.2025</a:t>
             </a:fld>
             <a:endParaRPr lang="de-DE"/>
           </a:p>
@@ -2298,7 +2370,7 @@
           <a:p>
             <a:fld id="{D999196E-D4C6-4B69-A492-D961CA2AEF86}" type="datetimeFigureOut">
               <a:rPr lang="de-DE" smtClean="0"/>
-              <a:t>17.04.2025</a:t>
+              <a:t>29.04.2025</a:t>
             </a:fld>
             <a:endParaRPr lang="de-DE"/>
           </a:p>
@@ -2609,7 +2681,7 @@
           <a:p>
             <a:fld id="{D999196E-D4C6-4B69-A492-D961CA2AEF86}" type="datetimeFigureOut">
               <a:rPr lang="de-DE" smtClean="0"/>
-              <a:t>17.04.2025</a:t>
+              <a:t>29.04.2025</a:t>
             </a:fld>
             <a:endParaRPr lang="de-DE"/>
           </a:p>
@@ -2897,7 +2969,7 @@
           <a:p>
             <a:fld id="{D999196E-D4C6-4B69-A492-D961CA2AEF86}" type="datetimeFigureOut">
               <a:rPr lang="de-DE" smtClean="0"/>
-              <a:t>17.04.2025</a:t>
+              <a:t>29.04.2025</a:t>
             </a:fld>
             <a:endParaRPr lang="de-DE"/>
           </a:p>
@@ -3138,7 +3210,7 @@
           <a:p>
             <a:fld id="{D999196E-D4C6-4B69-A492-D961CA2AEF86}" type="datetimeFigureOut">
               <a:rPr lang="de-DE" smtClean="0"/>
-              <a:t>17.04.2025</a:t>
+              <a:t>29.04.2025</a:t>
             </a:fld>
             <a:endParaRPr lang="de-DE"/>
           </a:p>
@@ -3569,8 +3641,8 @@
         </p:nvSpPr>
         <p:spPr>
           <a:xfrm>
-            <a:off x="159921" y="1767085"/>
-            <a:ext cx="2501729" cy="2750363"/>
+            <a:off x="76042" y="1522467"/>
+            <a:ext cx="2112219" cy="3061156"/>
           </a:xfrm>
           <a:prstGeom prst="roundRect">
             <a:avLst/>
@@ -3649,10 +3721,10 @@
       </p:sp>
       <p:sp>
         <p:nvSpPr>
-          <p:cNvPr id="5" name="Textfeld 4">
-            <a:extLst>
-              <a:ext uri="{FF2B5EF4-FFF2-40B4-BE49-F238E27FC236}">
-                <a16:creationId xmlns:a16="http://schemas.microsoft.com/office/drawing/2014/main" id="{E16B618F-BDBC-4486-8B54-D88B6EC8E637}"/>
+          <p:cNvPr id="6" name="Textfeld 5">
+            <a:extLst>
+              <a:ext uri="{FF2B5EF4-FFF2-40B4-BE49-F238E27FC236}">
+                <a16:creationId xmlns:a16="http://schemas.microsoft.com/office/drawing/2014/main" id="{05BFDD83-8A7C-4409-9548-42B073B0C9D0}"/>
               </a:ext>
             </a:extLst>
           </p:cNvPr>
@@ -3661,8 +3733,8 @@
         </p:nvSpPr>
         <p:spPr>
           <a:xfrm>
-            <a:off x="3069629" y="1522063"/>
-            <a:ext cx="2992020" cy="3240405"/>
+            <a:off x="8959816" y="1522467"/>
+            <a:ext cx="2891007" cy="2857548"/>
           </a:xfrm>
           <a:prstGeom prst="roundRect">
             <a:avLst/>
@@ -3688,47 +3760,43 @@
           <a:p>
             <a:pPr algn="ctr"/>
             <a:r>
+              <a:rPr lang="de-DE" sz="2400" dirty="0" err="1"/>
+              <a:t>student-directed</a:t>
+            </a:r>
+            <a:r>
               <a:rPr lang="de-DE" sz="2400" dirty="0"/>
-              <a:t>professional </a:t>
+              <a:t> </a:t>
             </a:r>
             <a:r>
               <a:rPr lang="de-DE" sz="2400" dirty="0" err="1"/>
-              <a:t>vision</a:t>
+              <a:t>behavior</a:t>
             </a:r>
             <a:endParaRPr lang="de-DE" sz="2400" dirty="0"/>
           </a:p>
           <a:p>
             <a:pPr algn="ctr"/>
-            <a:endParaRPr lang="de-DE" sz="2400" b="1" dirty="0"/>
+            <a:endParaRPr lang="de-DE" sz="2400" dirty="0"/>
           </a:p>
           <a:p>
             <a:pPr algn="ctr"/>
-            <a:endParaRPr lang="de-DE" sz="2400" b="1" dirty="0"/>
+            <a:endParaRPr lang="de-DE" sz="2400" dirty="0"/>
           </a:p>
           <a:p>
             <a:pPr algn="ctr"/>
-            <a:endParaRPr lang="de-DE" sz="2400" b="1" dirty="0"/>
+            <a:endParaRPr lang="de-DE" sz="2400" dirty="0"/>
           </a:p>
           <a:p>
             <a:pPr algn="ctr"/>
-            <a:endParaRPr lang="de-DE" sz="2400" b="1" dirty="0"/>
-          </a:p>
-          <a:p>
-            <a:pPr algn="ctr"/>
-            <a:endParaRPr lang="de-DE" sz="2400" b="1" dirty="0"/>
-          </a:p>
-          <a:p>
-            <a:pPr algn="ctr"/>
-            <a:endParaRPr lang="de-DE" sz="2400" b="1" dirty="0"/>
-          </a:p>
-        </p:txBody>
-      </p:sp>
-      <p:sp>
-        <p:nvSpPr>
-          <p:cNvPr id="6" name="Textfeld 5">
-            <a:extLst>
-              <a:ext uri="{FF2B5EF4-FFF2-40B4-BE49-F238E27FC236}">
-                <a16:creationId xmlns:a16="http://schemas.microsoft.com/office/drawing/2014/main" id="{05BFDD83-8A7C-4409-9548-42B073B0C9D0}"/>
+            <a:endParaRPr lang="de-DE" b="1" dirty="0"/>
+          </a:p>
+        </p:txBody>
+      </p:sp>
+      <p:sp>
+        <p:nvSpPr>
+          <p:cNvPr id="53" name="Textfeld 52">
+            <a:extLst>
+              <a:ext uri="{FF2B5EF4-FFF2-40B4-BE49-F238E27FC236}">
+                <a16:creationId xmlns:a16="http://schemas.microsoft.com/office/drawing/2014/main" id="{31FF52EA-BB8A-4921-8CCF-2ADDC3349751}"/>
               </a:ext>
             </a:extLst>
           </p:cNvPr>
@@ -3737,126 +3805,8 @@
         </p:nvSpPr>
         <p:spPr>
           <a:xfrm>
-            <a:off x="8745531" y="1767085"/>
-            <a:ext cx="3198820" cy="2758202"/>
-          </a:xfrm>
-          <a:prstGeom prst="roundRect">
-            <a:avLst/>
-          </a:prstGeom>
-          <a:solidFill>
-            <a:schemeClr val="bg2"/>
-          </a:solidFill>
-          <a:ln>
-            <a:solidFill>
-              <a:schemeClr val="tx1"/>
-            </a:solidFill>
-          </a:ln>
-        </p:spPr>
-        <p:txBody>
-          <a:bodyPr wrap="square" rtlCol="0">
-            <a:spAutoFit/>
-          </a:bodyPr>
-          <a:lstStyle/>
-          <a:p>
-            <a:pPr algn="ctr"/>
-            <a:endParaRPr lang="de-DE" b="1" dirty="0"/>
-          </a:p>
-          <a:p>
-            <a:pPr algn="ctr"/>
-            <a:r>
-              <a:rPr lang="de-DE" sz="2400" dirty="0" err="1"/>
-              <a:t>student-directed</a:t>
-            </a:r>
-            <a:r>
-              <a:rPr lang="de-DE" sz="2400" dirty="0"/>
-              <a:t> </a:t>
-            </a:r>
-            <a:r>
-              <a:rPr lang="de-DE" sz="2400" dirty="0" err="1"/>
-              <a:t>behavior</a:t>
-            </a:r>
-            <a:endParaRPr lang="de-DE" sz="2400" dirty="0"/>
-          </a:p>
-          <a:p>
-            <a:pPr algn="ctr"/>
-            <a:endParaRPr lang="de-DE" sz="2400" dirty="0"/>
-          </a:p>
-          <a:p>
-            <a:pPr algn="ctr"/>
-            <a:endParaRPr lang="de-DE" sz="2400" dirty="0"/>
-          </a:p>
-          <a:p>
-            <a:pPr algn="ctr"/>
-            <a:endParaRPr lang="de-DE" sz="2400" dirty="0"/>
-          </a:p>
-          <a:p>
-            <a:pPr algn="ctr"/>
-            <a:endParaRPr lang="de-DE" b="1" dirty="0"/>
-          </a:p>
-        </p:txBody>
-      </p:sp>
-      <p:cxnSp>
-        <p:nvCxnSpPr>
-          <p:cNvPr id="3" name="Gerade Verbindung mit Pfeil 2">
-            <a:extLst>
-              <a:ext uri="{FF2B5EF4-FFF2-40B4-BE49-F238E27FC236}">
-                <a16:creationId xmlns:a16="http://schemas.microsoft.com/office/drawing/2014/main" id="{216E32AC-B9A8-46BE-AA08-F62B3DBD91D6}"/>
-              </a:ext>
-            </a:extLst>
-          </p:cNvPr>
-          <p:cNvCxnSpPr>
-            <a:cxnSpLocks/>
-            <a:stCxn id="4" idx="3"/>
-            <a:endCxn id="5" idx="1"/>
-          </p:cNvCxnSpPr>
-          <p:nvPr/>
-        </p:nvCxnSpPr>
-        <p:spPr>
-          <a:xfrm flipV="1">
-            <a:off x="2661650" y="3142266"/>
-            <a:ext cx="407979" cy="1"/>
-          </a:xfrm>
-          <a:prstGeom prst="straightConnector1">
-            <a:avLst/>
-          </a:prstGeom>
-          <a:ln w="12700">
-            <a:solidFill>
-              <a:schemeClr val="tx1"/>
-            </a:solidFill>
-            <a:tailEnd type="triangle"/>
-          </a:ln>
-        </p:spPr>
-        <p:style>
-          <a:lnRef idx="1">
-            <a:schemeClr val="accent1"/>
-          </a:lnRef>
-          <a:fillRef idx="0">
-            <a:schemeClr val="accent1"/>
-          </a:fillRef>
-          <a:effectRef idx="0">
-            <a:schemeClr val="accent1"/>
-          </a:effectRef>
-          <a:fontRef idx="minor">
-            <a:schemeClr val="tx1"/>
-          </a:fontRef>
-        </p:style>
-      </p:cxnSp>
-      <p:sp>
-        <p:nvSpPr>
-          <p:cNvPr id="11" name="Textfeld 10">
-            <a:extLst>
-              <a:ext uri="{FF2B5EF4-FFF2-40B4-BE49-F238E27FC236}">
-                <a16:creationId xmlns:a16="http://schemas.microsoft.com/office/drawing/2014/main" id="{9D40E451-8356-413D-9642-E50C76A03686}"/>
-              </a:ext>
-            </a:extLst>
-          </p:cNvPr>
-          <p:cNvSpPr txBox="1"/>
-          <p:nvPr/>
-        </p:nvSpPr>
-        <p:spPr>
-          <a:xfrm>
-            <a:off x="3477608" y="2553753"/>
-            <a:ext cx="2193925" cy="783193"/>
+            <a:off x="9258434" y="2885144"/>
+            <a:ext cx="2367152" cy="1123712"/>
           </a:xfrm>
           <a:prstGeom prst="roundRect">
             <a:avLst/>
@@ -3879,7 +3829,15 @@
             <a:pPr algn="ctr"/>
             <a:r>
               <a:rPr lang="de-DE" sz="2000" dirty="0" err="1"/>
-              <a:t>visual</a:t>
+              <a:t>reacting</a:t>
+            </a:r>
+            <a:r>
+              <a:rPr lang="de-DE" sz="2000" dirty="0"/>
+              <a:t> to </a:t>
+            </a:r>
+            <a:r>
+              <a:rPr lang="de-DE" sz="2000" dirty="0" err="1"/>
+              <a:t>classroom</a:t>
             </a:r>
             <a:r>
               <a:rPr lang="de-DE" sz="2000" dirty="0"/>
@@ -3887,332 +3845,521 @@
             </a:r>
             <a:r>
               <a:rPr lang="de-DE" sz="2000" dirty="0" err="1"/>
-              <a:t>scanning</a:t>
-            </a:r>
-            <a:r>
-              <a:rPr lang="de-DE" sz="2000" dirty="0"/>
-              <a:t> (</a:t>
-            </a:r>
-            <a:r>
-              <a:rPr lang="de-DE" sz="2000" dirty="0" err="1"/>
-              <a:t>gaze</a:t>
-            </a:r>
-            <a:r>
-              <a:rPr lang="de-DE" sz="2000" dirty="0"/>
-              <a:t> </a:t>
-            </a:r>
-            <a:r>
-              <a:rPr lang="de-DE" sz="2000" dirty="0" err="1"/>
-              <a:t>efficiency</a:t>
-            </a:r>
-            <a:r>
-              <a:rPr lang="de-DE" sz="2000" dirty="0"/>
-              <a:t>)</a:t>
-            </a:r>
-          </a:p>
-        </p:txBody>
-      </p:sp>
-      <p:sp>
-        <p:nvSpPr>
-          <p:cNvPr id="12" name="Textfeld 11">
-            <a:extLst>
-              <a:ext uri="{FF2B5EF4-FFF2-40B4-BE49-F238E27FC236}">
-                <a16:creationId xmlns:a16="http://schemas.microsoft.com/office/drawing/2014/main" id="{47CF6F82-B69D-4724-849C-DF7E9AA84FD5}"/>
-              </a:ext>
-            </a:extLst>
-          </p:cNvPr>
-          <p:cNvSpPr txBox="1"/>
+              <a:t>disruption</a:t>
+            </a:r>
+            <a:endParaRPr lang="de-DE" sz="2000" dirty="0"/>
+          </a:p>
+        </p:txBody>
+      </p:sp>
+      <p:grpSp>
+        <p:nvGrpSpPr>
+          <p:cNvPr id="2" name="Gruppieren 1">
+            <a:extLst>
+              <a:ext uri="{FF2B5EF4-FFF2-40B4-BE49-F238E27FC236}">
+                <a16:creationId xmlns:a16="http://schemas.microsoft.com/office/drawing/2014/main" id="{38FC2BD1-3E2A-4365-B695-09A0D3D0AFA9}"/>
+              </a:ext>
+            </a:extLst>
+          </p:cNvPr>
+          <p:cNvGrpSpPr/>
           <p:nvPr/>
-        </p:nvSpPr>
-        <p:spPr>
+        </p:nvGrpSpPr>
+        <p:grpSpPr>
           <a:xfrm>
-            <a:off x="3477608" y="3636587"/>
-            <a:ext cx="2193925" cy="783193"/>
+            <a:off x="2524429" y="1522467"/>
+            <a:ext cx="2784891" cy="3249991"/>
+            <a:chOff x="2620143" y="1554484"/>
+            <a:chExt cx="2784891" cy="3249991"/>
           </a:xfrm>
-          <a:prstGeom prst="roundRect">
-            <a:avLst/>
-          </a:prstGeom>
-          <a:solidFill>
-            <a:schemeClr val="bg1"/>
-          </a:solidFill>
-          <a:ln>
+        </p:grpSpPr>
+        <p:sp>
+          <p:nvSpPr>
+            <p:cNvPr id="5" name="Textfeld 4">
+              <a:extLst>
+                <a:ext uri="{FF2B5EF4-FFF2-40B4-BE49-F238E27FC236}">
+                  <a16:creationId xmlns:a16="http://schemas.microsoft.com/office/drawing/2014/main" id="{E16B618F-BDBC-4486-8B54-D88B6EC8E637}"/>
+                </a:ext>
+              </a:extLst>
+            </p:cNvPr>
+            <p:cNvSpPr txBox="1"/>
+            <p:nvPr/>
+          </p:nvSpPr>
+          <p:spPr>
+            <a:xfrm>
+              <a:off x="2620143" y="1554484"/>
+              <a:ext cx="2784891" cy="3249991"/>
+            </a:xfrm>
+            <a:prstGeom prst="roundRect">
+              <a:avLst/>
+            </a:prstGeom>
             <a:solidFill>
+              <a:schemeClr val="bg2"/>
+            </a:solidFill>
+            <a:ln>
+              <a:solidFill>
+                <a:schemeClr val="tx1"/>
+              </a:solidFill>
+            </a:ln>
+          </p:spPr>
+          <p:txBody>
+            <a:bodyPr wrap="square" rtlCol="0">
+              <a:spAutoFit/>
+            </a:bodyPr>
+            <a:lstStyle/>
+            <a:p>
+              <a:pPr algn="ctr"/>
+              <a:endParaRPr lang="de-DE" b="1" dirty="0"/>
+            </a:p>
+            <a:p>
+              <a:pPr algn="ctr"/>
+              <a:r>
+                <a:rPr lang="de-DE" sz="2400" dirty="0"/>
+                <a:t>professional </a:t>
+              </a:r>
+              <a:r>
+                <a:rPr lang="de-DE" sz="2400" dirty="0" err="1"/>
+                <a:t>vision</a:t>
+              </a:r>
+              <a:endParaRPr lang="de-DE" sz="2400" dirty="0"/>
+            </a:p>
+            <a:p>
+              <a:pPr algn="ctr"/>
+              <a:endParaRPr lang="de-DE" sz="2400" b="1" dirty="0"/>
+            </a:p>
+            <a:p>
+              <a:pPr algn="ctr"/>
+              <a:endParaRPr lang="de-DE" sz="2400" b="1" dirty="0"/>
+            </a:p>
+            <a:p>
+              <a:pPr algn="ctr"/>
+              <a:endParaRPr lang="de-DE" sz="2400" b="1" dirty="0"/>
+            </a:p>
+            <a:p>
+              <a:pPr algn="ctr"/>
+              <a:endParaRPr lang="de-DE" sz="2400" b="1" dirty="0"/>
+            </a:p>
+            <a:p>
+              <a:pPr algn="ctr"/>
+              <a:endParaRPr lang="de-DE" sz="2400" b="1" dirty="0"/>
+            </a:p>
+            <a:p>
+              <a:pPr algn="ctr"/>
+              <a:endParaRPr lang="de-DE" sz="2400" b="1" dirty="0"/>
+            </a:p>
+          </p:txBody>
+        </p:sp>
+        <p:sp>
+          <p:nvSpPr>
+            <p:cNvPr id="11" name="Textfeld 10">
+              <a:extLst>
+                <a:ext uri="{FF2B5EF4-FFF2-40B4-BE49-F238E27FC236}">
+                  <a16:creationId xmlns:a16="http://schemas.microsoft.com/office/drawing/2014/main" id="{9D40E451-8356-413D-9642-E50C76A03686}"/>
+                </a:ext>
+              </a:extLst>
+            </p:cNvPr>
+            <p:cNvSpPr txBox="1"/>
+            <p:nvPr/>
+          </p:nvSpPr>
+          <p:spPr>
+            <a:xfrm>
+              <a:off x="2915793" y="2546004"/>
+              <a:ext cx="2193925" cy="783193"/>
+            </a:xfrm>
+            <a:prstGeom prst="roundRect">
+              <a:avLst/>
+            </a:prstGeom>
+            <a:solidFill>
+              <a:schemeClr val="bg1"/>
+            </a:solidFill>
+            <a:ln>
+              <a:solidFill>
+                <a:schemeClr val="tx1"/>
+              </a:solidFill>
+            </a:ln>
+          </p:spPr>
+          <p:txBody>
+            <a:bodyPr wrap="square" rtlCol="0">
+              <a:spAutoFit/>
+            </a:bodyPr>
+            <a:lstStyle/>
+            <a:p>
+              <a:pPr algn="ctr"/>
+              <a:r>
+                <a:rPr lang="de-DE" sz="2000" dirty="0" err="1"/>
+                <a:t>visual</a:t>
+              </a:r>
+              <a:r>
+                <a:rPr lang="de-DE" sz="2000" dirty="0"/>
+                <a:t> </a:t>
+              </a:r>
+              <a:r>
+                <a:rPr lang="de-DE" sz="2000" dirty="0" err="1"/>
+                <a:t>scanning</a:t>
+              </a:r>
+              <a:r>
+                <a:rPr lang="de-DE" sz="2000" dirty="0"/>
+                <a:t> (</a:t>
+              </a:r>
+              <a:r>
+                <a:rPr lang="de-DE" sz="2000" dirty="0" err="1"/>
+                <a:t>gaze</a:t>
+              </a:r>
+              <a:r>
+                <a:rPr lang="de-DE" sz="2000" dirty="0"/>
+                <a:t> </a:t>
+              </a:r>
+              <a:r>
+                <a:rPr lang="de-DE" sz="2000" dirty="0" err="1"/>
+                <a:t>efficiency</a:t>
+              </a:r>
+              <a:r>
+                <a:rPr lang="de-DE" sz="2000" dirty="0"/>
+                <a:t>)</a:t>
+              </a:r>
+            </a:p>
+          </p:txBody>
+        </p:sp>
+        <p:sp>
+          <p:nvSpPr>
+            <p:cNvPr id="12" name="Textfeld 11">
+              <a:extLst>
+                <a:ext uri="{FF2B5EF4-FFF2-40B4-BE49-F238E27FC236}">
+                  <a16:creationId xmlns:a16="http://schemas.microsoft.com/office/drawing/2014/main" id="{47CF6F82-B69D-4724-849C-DF7E9AA84FD5}"/>
+                </a:ext>
+              </a:extLst>
+            </p:cNvPr>
+            <p:cNvSpPr txBox="1"/>
+            <p:nvPr/>
+          </p:nvSpPr>
+          <p:spPr>
+            <a:xfrm>
+              <a:off x="2915793" y="3628838"/>
+              <a:ext cx="2193925" cy="783193"/>
+            </a:xfrm>
+            <a:prstGeom prst="roundRect">
+              <a:avLst/>
+            </a:prstGeom>
+            <a:solidFill>
+              <a:schemeClr val="bg1"/>
+            </a:solidFill>
+            <a:ln>
+              <a:solidFill>
+                <a:schemeClr val="tx1"/>
+              </a:solidFill>
+            </a:ln>
+          </p:spPr>
+          <p:txBody>
+            <a:bodyPr wrap="square" rtlCol="0">
+              <a:spAutoFit/>
+            </a:bodyPr>
+            <a:lstStyle/>
+            <a:p>
+              <a:pPr algn="ctr"/>
+              <a:r>
+                <a:rPr lang="de-DE" sz="2000" dirty="0" err="1"/>
+                <a:t>knowledge-based</a:t>
+              </a:r>
+              <a:r>
+                <a:rPr lang="de-DE" sz="2000" dirty="0"/>
+                <a:t> </a:t>
+              </a:r>
+              <a:r>
+                <a:rPr lang="de-DE" sz="2000" dirty="0" err="1"/>
+                <a:t>noticing</a:t>
+              </a:r>
+              <a:endParaRPr lang="de-DE" sz="2000" dirty="0"/>
+            </a:p>
+          </p:txBody>
+        </p:sp>
+        <p:cxnSp>
+          <p:nvCxnSpPr>
+            <p:cNvPr id="10" name="Gerade Verbindung mit Pfeil 9">
+              <a:extLst>
+                <a:ext uri="{FF2B5EF4-FFF2-40B4-BE49-F238E27FC236}">
+                  <a16:creationId xmlns:a16="http://schemas.microsoft.com/office/drawing/2014/main" id="{E3320B3A-1CD5-4F23-AF5B-72D2FC64533A}"/>
+                </a:ext>
+              </a:extLst>
+            </p:cNvPr>
+            <p:cNvCxnSpPr>
+              <a:cxnSpLocks/>
+              <a:stCxn id="11" idx="2"/>
+              <a:endCxn id="12" idx="0"/>
+            </p:cNvCxnSpPr>
+            <p:nvPr/>
+          </p:nvCxnSpPr>
+          <p:spPr>
+            <a:xfrm>
+              <a:off x="4012756" y="3329197"/>
+              <a:ext cx="0" cy="299641"/>
+            </a:xfrm>
+            <a:prstGeom prst="straightConnector1">
+              <a:avLst/>
+            </a:prstGeom>
+            <a:ln w="12700">
+              <a:tailEnd type="triangle"/>
+            </a:ln>
+          </p:spPr>
+          <p:style>
+            <a:lnRef idx="1">
+              <a:schemeClr val="dk1"/>
+            </a:lnRef>
+            <a:fillRef idx="0">
+              <a:schemeClr val="dk1"/>
+            </a:fillRef>
+            <a:effectRef idx="0">
+              <a:schemeClr val="dk1"/>
+            </a:effectRef>
+            <a:fontRef idx="minor">
               <a:schemeClr val="tx1"/>
+            </a:fontRef>
+          </p:style>
+        </p:cxnSp>
+      </p:grpSp>
+      <p:grpSp>
+        <p:nvGrpSpPr>
+          <p:cNvPr id="3" name="Gruppieren 2">
+            <a:extLst>
+              <a:ext uri="{FF2B5EF4-FFF2-40B4-BE49-F238E27FC236}">
+                <a16:creationId xmlns:a16="http://schemas.microsoft.com/office/drawing/2014/main" id="{9488C15B-1263-4A15-B38F-E1C3D5E2AF1B}"/>
+              </a:ext>
+            </a:extLst>
+          </p:cNvPr>
+          <p:cNvGrpSpPr/>
+          <p:nvPr/>
+        </p:nvGrpSpPr>
+        <p:grpSpPr>
+          <a:xfrm>
+            <a:off x="5729066" y="1522467"/>
+            <a:ext cx="2690892" cy="3517616"/>
+            <a:chOff x="5682067" y="1480587"/>
+            <a:chExt cx="2690892" cy="3517616"/>
+          </a:xfrm>
+        </p:grpSpPr>
+        <p:sp>
+          <p:nvSpPr>
+            <p:cNvPr id="16" name="Textfeld 15">
+              <a:extLst>
+                <a:ext uri="{FF2B5EF4-FFF2-40B4-BE49-F238E27FC236}">
+                  <a16:creationId xmlns:a16="http://schemas.microsoft.com/office/drawing/2014/main" id="{788A03D1-B794-45E7-9179-C6216D88F67C}"/>
+                </a:ext>
+              </a:extLst>
+            </p:cNvPr>
+            <p:cNvSpPr txBox="1"/>
+            <p:nvPr/>
+          </p:nvSpPr>
+          <p:spPr>
+            <a:xfrm>
+              <a:off x="5682067" y="1480587"/>
+              <a:ext cx="2690892" cy="3517616"/>
+            </a:xfrm>
+            <a:prstGeom prst="roundRect">
+              <a:avLst/>
+            </a:prstGeom>
+            <a:solidFill>
+              <a:schemeClr val="bg2"/>
             </a:solidFill>
-          </a:ln>
-        </p:spPr>
-        <p:txBody>
-          <a:bodyPr wrap="square" rtlCol="0">
-            <a:spAutoFit/>
-          </a:bodyPr>
-          <a:lstStyle/>
-          <a:p>
-            <a:pPr algn="ctr"/>
-            <a:r>
-              <a:rPr lang="de-DE" sz="2000" dirty="0" err="1"/>
-              <a:t>knowledge-based</a:t>
-            </a:r>
-            <a:r>
-              <a:rPr lang="de-DE" sz="2000" dirty="0"/>
-              <a:t> </a:t>
-            </a:r>
-            <a:r>
-              <a:rPr lang="de-DE" sz="2000" dirty="0" err="1"/>
-              <a:t>noticing</a:t>
-            </a:r>
-            <a:endParaRPr lang="de-DE" sz="2000" dirty="0"/>
-          </a:p>
-        </p:txBody>
-      </p:sp>
-      <p:sp>
-        <p:nvSpPr>
-          <p:cNvPr id="16" name="Textfeld 15">
-            <a:extLst>
-              <a:ext uri="{FF2B5EF4-FFF2-40B4-BE49-F238E27FC236}">
-                <a16:creationId xmlns:a16="http://schemas.microsoft.com/office/drawing/2014/main" id="{788A03D1-B794-45E7-9179-C6216D88F67C}"/>
-              </a:ext>
-            </a:extLst>
-          </p:cNvPr>
-          <p:cNvSpPr txBox="1"/>
-          <p:nvPr/>
-        </p:nvSpPr>
-        <p:spPr>
-          <a:xfrm>
-            <a:off x="6469629" y="2205839"/>
-            <a:ext cx="1867921" cy="1872853"/>
-          </a:xfrm>
-          <a:prstGeom prst="roundRect">
-            <a:avLst/>
-          </a:prstGeom>
-          <a:solidFill>
-            <a:schemeClr val="bg2"/>
-          </a:solidFill>
-          <a:ln>
+            <a:ln>
+              <a:solidFill>
+                <a:schemeClr val="tx1"/>
+              </a:solidFill>
+            </a:ln>
+          </p:spPr>
+          <p:txBody>
+            <a:bodyPr wrap="square" rtlCol="0">
+              <a:spAutoFit/>
+            </a:bodyPr>
+            <a:lstStyle/>
+            <a:p>
+              <a:pPr algn="ctr"/>
+              <a:endParaRPr lang="de-DE" sz="1400" b="1" dirty="0"/>
+            </a:p>
+            <a:p>
+              <a:pPr algn="ctr"/>
+              <a:r>
+                <a:rPr lang="de-DE" sz="2400" dirty="0" err="1"/>
+                <a:t>knowledge-based</a:t>
+              </a:r>
+              <a:r>
+                <a:rPr lang="de-DE" sz="2400" dirty="0"/>
+                <a:t> </a:t>
+              </a:r>
+              <a:r>
+                <a:rPr lang="de-DE" sz="2400" dirty="0" err="1"/>
+                <a:t>reasoning</a:t>
+              </a:r>
+              <a:endParaRPr lang="de-DE" sz="2400" dirty="0"/>
+            </a:p>
+            <a:p>
+              <a:pPr algn="ctr"/>
+              <a:endParaRPr lang="de-DE" sz="2400" dirty="0"/>
+            </a:p>
+            <a:p>
+              <a:pPr algn="ctr"/>
+              <a:endParaRPr lang="de-DE" sz="2400" dirty="0"/>
+            </a:p>
+            <a:p>
+              <a:pPr algn="ctr"/>
+              <a:endParaRPr lang="de-DE" sz="2400" dirty="0"/>
+            </a:p>
+            <a:p>
+              <a:pPr algn="ctr"/>
+              <a:endParaRPr lang="de-DE" sz="2400" dirty="0"/>
+            </a:p>
+            <a:p>
+              <a:pPr algn="ctr"/>
+              <a:endParaRPr lang="de-DE" sz="2400" dirty="0"/>
+            </a:p>
+            <a:p>
+              <a:pPr algn="ctr"/>
+              <a:endParaRPr lang="de-DE" sz="2400" dirty="0"/>
+            </a:p>
+          </p:txBody>
+        </p:sp>
+        <p:sp>
+          <p:nvSpPr>
+            <p:cNvPr id="13" name="Textfeld 12">
+              <a:extLst>
+                <a:ext uri="{FF2B5EF4-FFF2-40B4-BE49-F238E27FC236}">
+                  <a16:creationId xmlns:a16="http://schemas.microsoft.com/office/drawing/2014/main" id="{687BC613-2B38-4EB9-A500-DD27CE840820}"/>
+                </a:ext>
+              </a:extLst>
+            </p:cNvPr>
+            <p:cNvSpPr txBox="1"/>
+            <p:nvPr/>
+          </p:nvSpPr>
+          <p:spPr>
+            <a:xfrm>
+              <a:off x="5914684" y="2752092"/>
+              <a:ext cx="2193925" cy="783193"/>
+            </a:xfrm>
+            <a:prstGeom prst="roundRect">
+              <a:avLst/>
+            </a:prstGeom>
             <a:solidFill>
+              <a:schemeClr val="bg1"/>
+            </a:solidFill>
+            <a:ln>
+              <a:solidFill>
+                <a:schemeClr val="tx1"/>
+              </a:solidFill>
+            </a:ln>
+          </p:spPr>
+          <p:txBody>
+            <a:bodyPr wrap="square" rtlCol="0">
+              <a:spAutoFit/>
+            </a:bodyPr>
+            <a:lstStyle/>
+            <a:p>
+              <a:pPr algn="ctr"/>
+              <a:r>
+                <a:rPr lang="de-DE" sz="2000" dirty="0" err="1"/>
+                <a:t>disruption</a:t>
+              </a:r>
+              <a:r>
+                <a:rPr lang="de-DE" sz="2000" dirty="0"/>
+                <a:t> </a:t>
+              </a:r>
+              <a:r>
+                <a:rPr lang="de-DE" sz="2000" dirty="0" err="1"/>
+                <a:t>evaluation</a:t>
+              </a:r>
+              <a:endParaRPr lang="de-DE" sz="2000" dirty="0"/>
+            </a:p>
+          </p:txBody>
+        </p:sp>
+        <p:sp>
+          <p:nvSpPr>
+            <p:cNvPr id="14" name="Textfeld 13">
+              <a:extLst>
+                <a:ext uri="{FF2B5EF4-FFF2-40B4-BE49-F238E27FC236}">
+                  <a16:creationId xmlns:a16="http://schemas.microsoft.com/office/drawing/2014/main" id="{2CA634B0-2179-4260-9524-88AE3E6D6885}"/>
+                </a:ext>
+              </a:extLst>
+            </p:cNvPr>
+            <p:cNvSpPr txBox="1"/>
+            <p:nvPr/>
+          </p:nvSpPr>
+          <p:spPr>
+            <a:xfrm>
+              <a:off x="5914684" y="3834926"/>
+              <a:ext cx="2193925" cy="783193"/>
+            </a:xfrm>
+            <a:prstGeom prst="roundRect">
+              <a:avLst/>
+            </a:prstGeom>
+            <a:solidFill>
+              <a:schemeClr val="bg1"/>
+            </a:solidFill>
+            <a:ln>
+              <a:solidFill>
+                <a:schemeClr val="tx1"/>
+              </a:solidFill>
+            </a:ln>
+          </p:spPr>
+          <p:txBody>
+            <a:bodyPr wrap="square" rtlCol="0">
+              <a:spAutoFit/>
+            </a:bodyPr>
+            <a:lstStyle/>
+            <a:p>
+              <a:pPr algn="ctr"/>
+              <a:r>
+                <a:rPr lang="de-DE" sz="2000" dirty="0" err="1"/>
+                <a:t>ressource</a:t>
+              </a:r>
+              <a:r>
+                <a:rPr lang="de-DE" sz="2000" dirty="0"/>
+                <a:t> </a:t>
+              </a:r>
+              <a:r>
+                <a:rPr lang="de-DE" sz="2000" dirty="0" err="1"/>
+                <a:t>evaluation</a:t>
+              </a:r>
+              <a:endParaRPr lang="de-DE" sz="2000" dirty="0"/>
+            </a:p>
+          </p:txBody>
+        </p:sp>
+        <p:cxnSp>
+          <p:nvCxnSpPr>
+            <p:cNvPr id="18" name="Gerade Verbindung mit Pfeil 17">
+              <a:extLst>
+                <a:ext uri="{FF2B5EF4-FFF2-40B4-BE49-F238E27FC236}">
+                  <a16:creationId xmlns:a16="http://schemas.microsoft.com/office/drawing/2014/main" id="{AA9571B3-9964-4865-B68D-64DC0FA175FF}"/>
+                </a:ext>
+              </a:extLst>
+            </p:cNvPr>
+            <p:cNvCxnSpPr>
+              <a:cxnSpLocks/>
+            </p:cNvCxnSpPr>
+            <p:nvPr/>
+          </p:nvCxnSpPr>
+          <p:spPr>
+            <a:xfrm>
+              <a:off x="7020679" y="3535285"/>
+              <a:ext cx="0" cy="299641"/>
+            </a:xfrm>
+            <a:prstGeom prst="straightConnector1">
+              <a:avLst/>
+            </a:prstGeom>
+            <a:ln w="12700">
+              <a:tailEnd type="triangle"/>
+            </a:ln>
+          </p:spPr>
+          <p:style>
+            <a:lnRef idx="1">
+              <a:schemeClr val="dk1"/>
+            </a:lnRef>
+            <a:fillRef idx="0">
+              <a:schemeClr val="dk1"/>
+            </a:fillRef>
+            <a:effectRef idx="0">
+              <a:schemeClr val="dk1"/>
+            </a:effectRef>
+            <a:fontRef idx="minor">
               <a:schemeClr val="tx1"/>
-            </a:solidFill>
-          </a:ln>
-        </p:spPr>
-        <p:txBody>
-          <a:bodyPr wrap="square" rtlCol="0">
-            <a:spAutoFit/>
-          </a:bodyPr>
-          <a:lstStyle/>
-          <a:p>
-            <a:pPr algn="ctr"/>
-            <a:endParaRPr lang="de-DE" sz="1400" b="1" dirty="0"/>
-          </a:p>
-          <a:p>
-            <a:pPr algn="ctr"/>
-            <a:r>
-              <a:rPr lang="de-DE" sz="2400" dirty="0" err="1"/>
-              <a:t>knowledge-based</a:t>
-            </a:r>
-            <a:r>
-              <a:rPr lang="de-DE" sz="2400" dirty="0"/>
-              <a:t> </a:t>
-            </a:r>
-            <a:r>
-              <a:rPr lang="de-DE" sz="2400" dirty="0" err="1"/>
-              <a:t>reasoning</a:t>
-            </a:r>
-            <a:endParaRPr lang="de-DE" sz="2400" dirty="0"/>
-          </a:p>
-          <a:p>
-            <a:pPr algn="ctr"/>
-            <a:endParaRPr lang="de-DE" sz="1800" dirty="0"/>
-          </a:p>
-        </p:txBody>
-      </p:sp>
-      <p:cxnSp>
-        <p:nvCxnSpPr>
-          <p:cNvPr id="33" name="Gerade Verbindung mit Pfeil 32">
-            <a:extLst>
-              <a:ext uri="{FF2B5EF4-FFF2-40B4-BE49-F238E27FC236}">
-                <a16:creationId xmlns:a16="http://schemas.microsoft.com/office/drawing/2014/main" id="{3914D202-863F-4433-AF5F-12A385953860}"/>
-              </a:ext>
-            </a:extLst>
-          </p:cNvPr>
-          <p:cNvCxnSpPr>
-            <a:cxnSpLocks/>
-            <a:stCxn id="5" idx="3"/>
-            <a:endCxn id="16" idx="1"/>
-          </p:cNvCxnSpPr>
-          <p:nvPr/>
-        </p:nvCxnSpPr>
-        <p:spPr>
-          <a:xfrm>
-            <a:off x="6061649" y="3142266"/>
-            <a:ext cx="407980" cy="0"/>
-          </a:xfrm>
-          <a:prstGeom prst="straightConnector1">
-            <a:avLst/>
-          </a:prstGeom>
-          <a:ln w="12700">
-            <a:tailEnd type="triangle"/>
-          </a:ln>
-        </p:spPr>
-        <p:style>
-          <a:lnRef idx="1">
-            <a:schemeClr val="dk1"/>
-          </a:lnRef>
-          <a:fillRef idx="0">
-            <a:schemeClr val="dk1"/>
-          </a:fillRef>
-          <a:effectRef idx="0">
-            <a:schemeClr val="dk1"/>
-          </a:effectRef>
-          <a:fontRef idx="minor">
-            <a:schemeClr val="tx1"/>
-          </a:fontRef>
-        </p:style>
-      </p:cxnSp>
-      <p:cxnSp>
-        <p:nvCxnSpPr>
-          <p:cNvPr id="51" name="Gerade Verbindung mit Pfeil 50">
-            <a:extLst>
-              <a:ext uri="{FF2B5EF4-FFF2-40B4-BE49-F238E27FC236}">
-                <a16:creationId xmlns:a16="http://schemas.microsoft.com/office/drawing/2014/main" id="{8F6C4BE1-B4F0-456A-A67B-FE826FE33B0C}"/>
-              </a:ext>
-            </a:extLst>
-          </p:cNvPr>
-          <p:cNvCxnSpPr>
-            <a:cxnSpLocks/>
-            <a:stCxn id="16" idx="3"/>
-            <a:endCxn id="6" idx="1"/>
-          </p:cNvCxnSpPr>
-          <p:nvPr/>
-        </p:nvCxnSpPr>
-        <p:spPr>
-          <a:xfrm>
-            <a:off x="8337550" y="3142266"/>
-            <a:ext cx="407981" cy="3920"/>
-          </a:xfrm>
-          <a:prstGeom prst="straightConnector1">
-            <a:avLst/>
-          </a:prstGeom>
-          <a:ln w="12700">
-            <a:tailEnd type="triangle"/>
-          </a:ln>
-        </p:spPr>
-        <p:style>
-          <a:lnRef idx="1">
-            <a:schemeClr val="dk1"/>
-          </a:lnRef>
-          <a:fillRef idx="0">
-            <a:schemeClr val="dk1"/>
-          </a:fillRef>
-          <a:effectRef idx="0">
-            <a:schemeClr val="dk1"/>
-          </a:effectRef>
-          <a:fontRef idx="minor">
-            <a:schemeClr val="tx1"/>
-          </a:fontRef>
-        </p:style>
-      </p:cxnSp>
-      <p:sp>
-        <p:nvSpPr>
-          <p:cNvPr id="53" name="Textfeld 52">
-            <a:extLst>
-              <a:ext uri="{FF2B5EF4-FFF2-40B4-BE49-F238E27FC236}">
-                <a16:creationId xmlns:a16="http://schemas.microsoft.com/office/drawing/2014/main" id="{31FF52EA-BB8A-4921-8CCF-2ADDC3349751}"/>
-              </a:ext>
-            </a:extLst>
-          </p:cNvPr>
-          <p:cNvSpPr txBox="1"/>
-          <p:nvPr/>
-        </p:nvSpPr>
-        <p:spPr>
-          <a:xfrm>
-            <a:off x="9028606" y="3142266"/>
-            <a:ext cx="2632669" cy="783193"/>
-          </a:xfrm>
-          <a:prstGeom prst="roundRect">
-            <a:avLst/>
-          </a:prstGeom>
-          <a:solidFill>
-            <a:schemeClr val="bg1"/>
-          </a:solidFill>
-          <a:ln>
-            <a:solidFill>
-              <a:schemeClr val="tx1"/>
-            </a:solidFill>
-          </a:ln>
-        </p:spPr>
-        <p:txBody>
-          <a:bodyPr wrap="square" rtlCol="0">
-            <a:spAutoFit/>
-          </a:bodyPr>
-          <a:lstStyle/>
-          <a:p>
-            <a:pPr algn="ctr"/>
-            <a:r>
-              <a:rPr lang="de-DE" sz="2000" dirty="0" err="1"/>
-              <a:t>reacting</a:t>
-            </a:r>
-            <a:r>
-              <a:rPr lang="de-DE" sz="2000" dirty="0"/>
-              <a:t> to </a:t>
-            </a:r>
-            <a:r>
-              <a:rPr lang="de-DE" sz="2000" dirty="0" err="1"/>
-              <a:t>classroom</a:t>
-            </a:r>
-            <a:r>
-              <a:rPr lang="de-DE" sz="2000" dirty="0"/>
-              <a:t> </a:t>
-            </a:r>
-            <a:r>
-              <a:rPr lang="de-DE" sz="2000" dirty="0" err="1"/>
-              <a:t>disruption</a:t>
-            </a:r>
-            <a:endParaRPr lang="de-DE" sz="2000" dirty="0"/>
-          </a:p>
-        </p:txBody>
-      </p:sp>
-      <p:cxnSp>
-        <p:nvCxnSpPr>
-          <p:cNvPr id="10" name="Gerade Verbindung mit Pfeil 9">
-            <a:extLst>
-              <a:ext uri="{FF2B5EF4-FFF2-40B4-BE49-F238E27FC236}">
-                <a16:creationId xmlns:a16="http://schemas.microsoft.com/office/drawing/2014/main" id="{E3320B3A-1CD5-4F23-AF5B-72D2FC64533A}"/>
-              </a:ext>
-            </a:extLst>
-          </p:cNvPr>
-          <p:cNvCxnSpPr>
-            <a:cxnSpLocks/>
-            <a:stCxn id="11" idx="2"/>
-            <a:endCxn id="12" idx="0"/>
-          </p:cNvCxnSpPr>
-          <p:nvPr/>
-        </p:nvCxnSpPr>
-        <p:spPr>
-          <a:xfrm>
-            <a:off x="4574571" y="3336946"/>
-            <a:ext cx="0" cy="299641"/>
-          </a:xfrm>
-          <a:prstGeom prst="straightConnector1">
-            <a:avLst/>
-          </a:prstGeom>
-          <a:ln w="12700">
-            <a:tailEnd type="triangle"/>
-          </a:ln>
-        </p:spPr>
-        <p:style>
-          <a:lnRef idx="1">
-            <a:schemeClr val="dk1"/>
-          </a:lnRef>
-          <a:fillRef idx="0">
-            <a:schemeClr val="dk1"/>
-          </a:fillRef>
-          <a:effectRef idx="0">
-            <a:schemeClr val="dk1"/>
-          </a:effectRef>
-          <a:fontRef idx="minor">
-            <a:schemeClr val="tx1"/>
-          </a:fontRef>
-        </p:style>
-      </p:cxnSp>
+            </a:fontRef>
+          </p:style>
+        </p:cxnSp>
+      </p:grpSp>
     </p:spTree>
     <p:extLst>
       <p:ext uri="{BB962C8B-B14F-4D97-AF65-F5344CB8AC3E}">

</xml_diff>